<commit_message>
Corrige arquivos publicados da Aula 4 apos re-verificacao
- Lista/Gabarito/Tabela: titulo interno voltava "4A" (residuo da fusao
  desfeita); corrigido para "4" simples.
- O PDF/pptx "limpos" publicados estavam dessincronizados do deck real
  desde que o slide de Atividades foi recriado no arquivo principal -
  regenerados do zero a partir do .pptx mestre ja verificado (21 paginas:
  19 de conteudo sem Verificacao Rapida + 2 de Atividades).

Co-Authored-By: Claude Sonnet 5 <noreply@anthropic.com>
</commit_message>
<xml_diff>
--- a/content/2026-2/cea055-estatistica-probabilidade/04-tecnicas-de-contagem/Aula_04_Tecnicas_de_Contagem_SITE.pptx
+++ b/content/2026-2/cea055-estatistica-probabilidade/04-tecnicas-de-contagem/Aula_04_Tecnicas_de_Contagem_SITE.pptx
@@ -27,6 +27,8 @@
     <p:sldId id="611" r:id="rId18"/>
     <p:sldId id="612" r:id="rId19"/>
     <p:sldId id="613" r:id="rId20"/>
+    <p:sldId id="624" r:id="rId31"/>
+    <p:sldId id="625" r:id="rId32"/>
   </p:sldIdLst>
   <p:sldSz cx="12192000" cy="6858000"/>
   <p:notesSz cx="7099300" cy="10234613"/>
@@ -7721,6 +7723,224 @@
         <p14:creationId xmlns:p14="http://schemas.microsoft.com/office/powerpoint/2010/main" val="1572541850"/>
       </p:ext>
     </p:extLst>
+  </p:cSld>
+  <p:clrMapOvr>
+    <a:masterClrMapping/>
+  </p:clrMapOvr>
+</p:sld>
+</file>
+
+<file path=ppt/slides/slide24.xml><?xml version="1.0" encoding="utf-8"?>
+<p:sld xmlns:a="http://schemas.openxmlformats.org/drawingml/2006/main" xmlns:p="http://schemas.openxmlformats.org/presentationml/2006/main" xmlns:r="http://schemas.openxmlformats.org/officeDocument/2006/relationships">
+  <p:cSld>
+    <p:spTree>
+      <p:nvGrpSpPr>
+        <p:cNvPr id="1" name=""/>
+        <p:cNvGrpSpPr/>
+        <p:nvPr/>
+      </p:nvGrpSpPr>
+      <p:grpSpPr/>
+      <p:sp>
+        <p:nvSpPr>
+          <p:cNvPr id="6" name="CaixaDeTexto 5">
+            <a:extLst>
+              <a:ext uri="{FF2B5EF4-FFF2-40B4-BE49-F238E27FC236}">
+                <a16:creationId xmlns:a16="http://schemas.microsoft.com/office/drawing/2014/main" id="{720B10DA-C761-4DEE-8D86-E170E1C2E981}"/>
+              </a:ext>
+            </a:extLst>
+          </p:cNvPr>
+          <p:cNvSpPr txBox="1"/>
+          <p:nvPr/>
+        </p:nvSpPr>
+        <p:spPr>
+          <a:xfrm>
+            <a:off x="623269" y="671347"/>
+            <a:ext cx="10748061" cy="2826287"/>
+          </a:xfrm>
+          <a:prstGeom prst="rect">
+            <a:avLst/>
+          </a:prstGeom>
+          <a:noFill/>
+        </p:spPr>
+        <p:txBody>
+          <a:bodyPr wrap="square" rtlCol="0">
+            <a:spAutoFit/>
+          </a:bodyPr>
+          <a:lstStyle/>
+          <a:p>
+            <a:r>
+              <a:rPr b="1" sz="2800"/>
+              <a:t>Leitura recomendada:</a:t>
+            </a:r>
+          </a:p>
+          <a:p>
+            <a:r>
+              <a:rPr b="0" sz="2800"/>
+              <a:t>Bussab &amp; Morettin — Cap. 5 (5.2)</a:t>
+            </a:r>
+          </a:p>
+          <a:p>
+            <a:r>
+              <a:rPr b="0" sz="2800"/>
+              <a:t>Montgomery &amp; Runger — Cap. 2 (2.2)</a:t>
+            </a:r>
+          </a:p>
+          <a:p>
+            <a:r>
+              <a:rPr b="0" sz="2800"/>
+              <a:t>Magalhães &amp; Lima — Cap. 2 (2.1)</a:t>
+            </a:r>
+          </a:p>
+          <a:p>
+            <a:r>
+              <a:rPr b="0" sz="2800"/>
+              <a:t>Morettin — Cap. 2 (2.2, 2.3)</a:t>
+            </a:r>
+          </a:p>
+        </p:txBody>
+      </p:sp>
+      <p:sp>
+        <p:nvSpPr>
+          <p:cNvPr id="3" name="CaixaDeTexto 2">
+            <a:extLst>
+              <a:ext uri="{FF2B5EF4-FFF2-40B4-BE49-F238E27FC236}">
+                <a16:creationId xmlns:a16="http://schemas.microsoft.com/office/drawing/2014/main" id="{19131A04-B5D6-4211-8B49-4615DE5797E9}"/>
+              </a:ext>
+            </a:extLst>
+          </p:cNvPr>
+          <p:cNvSpPr txBox="1"/>
+          <p:nvPr/>
+        </p:nvSpPr>
+        <p:spPr>
+          <a:xfrm>
+            <a:off x="361188" y="6463893"/>
+            <a:ext cx="7772400" cy="308152"/>
+          </a:xfrm>
+          <a:prstGeom prst="rect">
+            <a:avLst/>
+          </a:prstGeom>
+          <a:noFill/>
+        </p:spPr>
+        <p:txBody>
+          <a:bodyPr wrap="none" rtlCol="0">
+            <a:spAutoFit/>
+          </a:bodyPr>
+          <a:lstStyle/>
+          <a:p>
+            <a:r>
+              <a:rPr lang="pt-BR" sz="1400" dirty="0"/>
+              <a:t>CEA055 – Estatística e Probabilidade – Prof. Marcos Goulart Lima</a:t>
+            </a:r>
+          </a:p>
+        </p:txBody>
+      </p:sp>
+    </p:spTree>
+  </p:cSld>
+  <p:clrMapOvr>
+    <a:masterClrMapping/>
+  </p:clrMapOvr>
+</p:sld>
+</file>
+
+<file path=ppt/slides/slide25.xml><?xml version="1.0" encoding="utf-8"?>
+<p:sld xmlns:a="http://schemas.openxmlformats.org/drawingml/2006/main" xmlns:p="http://schemas.openxmlformats.org/presentationml/2006/main" xmlns:r="http://schemas.openxmlformats.org/officeDocument/2006/relationships">
+  <p:cSld>
+    <p:spTree>
+      <p:nvGrpSpPr>
+        <p:cNvPr id="1" name=""/>
+        <p:cNvGrpSpPr/>
+        <p:nvPr/>
+      </p:nvGrpSpPr>
+      <p:grpSpPr/>
+      <p:sp>
+        <p:nvSpPr>
+          <p:cNvPr id="6" name="CaixaDeTexto 5">
+            <a:extLst>
+              <a:ext uri="{FF2B5EF4-FFF2-40B4-BE49-F238E27FC236}">
+                <a16:creationId xmlns:a16="http://schemas.microsoft.com/office/drawing/2014/main" id="{720B10DA-C761-4DEE-8D86-E170E1C2E981}"/>
+              </a:ext>
+            </a:extLst>
+          </p:cNvPr>
+          <p:cNvSpPr txBox="1"/>
+          <p:nvPr/>
+        </p:nvSpPr>
+        <p:spPr>
+          <a:xfrm>
+            <a:off x="623269" y="671347"/>
+            <a:ext cx="10748061" cy="2826287"/>
+          </a:xfrm>
+          <a:prstGeom prst="rect">
+            <a:avLst/>
+          </a:prstGeom>
+          <a:noFill/>
+        </p:spPr>
+        <p:txBody>
+          <a:bodyPr wrap="square" rtlCol="0">
+            <a:spAutoFit/>
+          </a:bodyPr>
+          <a:lstStyle/>
+          <a:p>
+            <a:r>
+              <a:rPr b="1" sz="2800"/>
+              <a:t>Exercícios recomendados:</a:t>
+            </a:r>
+          </a:p>
+          <a:p>
+            <a:r>
+              <a:rPr b="0" sz="2800"/>
+              <a:t>Bussab &amp; Morettin, Cap. 5: Problema 11</a:t>
+            </a:r>
+          </a:p>
+          <a:p>
+            <a:r>
+              <a:rPr b="0" sz="2800"/>
+              <a:t>Montgomery &amp; Runger, Cap. 2: Exercícios 2.2.3, 2.2.4, 2.2.5, 2.2.6, 2.2.7, 2.2.9, 2.2.10, 2.2.11, 2.2.12 e 2.2.14</a:t>
+            </a:r>
+          </a:p>
+          <a:p>
+            <a:r>
+              <a:rPr b="0" sz="2800"/>
+              <a:t>Morettin, Cap. 2: Exercícios 5, 6, 7, 8, 9, 10, 11, 12, 13 e 17</a:t>
+            </a:r>
+          </a:p>
+        </p:txBody>
+      </p:sp>
+      <p:sp>
+        <p:nvSpPr>
+          <p:cNvPr id="3" name="CaixaDeTexto 2">
+            <a:extLst>
+              <a:ext uri="{FF2B5EF4-FFF2-40B4-BE49-F238E27FC236}">
+                <a16:creationId xmlns:a16="http://schemas.microsoft.com/office/drawing/2014/main" id="{19131A04-B5D6-4211-8B49-4615DE5797E9}"/>
+              </a:ext>
+            </a:extLst>
+          </p:cNvPr>
+          <p:cNvSpPr txBox="1"/>
+          <p:nvPr/>
+        </p:nvSpPr>
+        <p:spPr>
+          <a:xfrm>
+            <a:off x="361188" y="6463893"/>
+            <a:ext cx="7772400" cy="308152"/>
+          </a:xfrm>
+          <a:prstGeom prst="rect">
+            <a:avLst/>
+          </a:prstGeom>
+          <a:noFill/>
+        </p:spPr>
+        <p:txBody>
+          <a:bodyPr wrap="none" rtlCol="0">
+            <a:spAutoFit/>
+          </a:bodyPr>
+          <a:lstStyle/>
+          <a:p>
+            <a:r>
+              <a:rPr lang="pt-BR" sz="1400" dirty="0"/>
+              <a:t>CEA055 – Estatística e Probabilidade – Prof. Marcos Goulart Lima</a:t>
+            </a:r>
+          </a:p>
+        </p:txBody>
+      </p:sp>
+    </p:spTree>
   </p:cSld>
   <p:clrMapOvr>
     <a:masterClrMapping/>

</xml_diff>